<commit_message>
refactor(decks): enforce 15-slide cap per deck
Trimmed 6 decks that exceeded the cap:
- 01 Flagship: 18 -> 14 (dropped 3 trailing theme-mention statements,
  which each have a dedicated thematic deck)
- 02 SmartGate Spotlight: 20 -> 15 (dropped form-mid-fill evidence,
  3-channel-alert evidence, PDF export, offline queue evidence, RBAC
  statement; merged Telegram caption to cover the 3-channel point)
- 03 Staff Attendance Spotlight: 20 -> 15 (dropped PIN modal evidence,
  weak-GPS evidence, absence modal evidence, daily-summary evidence,
  eBadge statement)
- 04 Security & Trust: 17 -> 15 (dropped RBAC + rate-limit evidence
  slides, kept the statements)
- 08 Kente Executive Design: 16 -> 15 (dropped redundant
  gold-signature statement)
- 10 The Staff Experience: 16 -> 15 (dropped 2-apps-icons evidence,
  already shown in deck 05)

All 13 decks now in [14, 15]. Manifests updated. Suite cover regenerated.

Co-Authored-By: Claude Opus 4.7 (1M context) <noreply@anthropic.com>
</commit_message>
<xml_diff>
--- a/decks/output/01-flagship-v0.pptx
+++ b/decks/output/01-flagship-v0.pptx
@@ -19,10 +19,6 @@
     <p:sldId id="267" r:id="rId18"/>
     <p:sldId id="268" r:id="rId19"/>
     <p:sldId id="269" r:id="rId20"/>
-    <p:sldId id="270" r:id="rId21"/>
-    <p:sldId id="271" r:id="rId22"/>
-    <p:sldId id="272" r:id="rId23"/>
-    <p:sldId id="273" r:id="rId24"/>
   </p:sldIdLst>
   <p:sldSz cx="12192000" cy="6858000" type="screen4x3"/>
   <p:notesSz cx="6858000" cy="9144000"/>
@@ -3621,7 +3617,7 @@
                 </a:solidFill>
                 <a:latin typeface="DM Sans"/>
               </a:rPr>
-              <a:t>01 · The Story So Far · 10/18</a:t>
+              <a:t>01 · The Story So Far · 10/14</a:t>
             </a:r>
           </a:p>
         </p:txBody>
@@ -3776,7 +3772,7 @@
                 </a:solidFill>
                 <a:latin typeface="DM Sans"/>
               </a:rPr>
-              <a:t>01 · The Story So Far · 11/18</a:t>
+              <a:t>01 · The Story So Far · 11/14</a:t>
             </a:r>
           </a:p>
         </p:txBody>
@@ -4066,7 +4062,7 @@
                 </a:solidFill>
                 <a:latin typeface="DM Sans"/>
               </a:rPr>
-              <a:t>01 · The Story So Far · 12/18</a:t>
+              <a:t>01 · The Story So Far · 12/14</a:t>
             </a:r>
           </a:p>
         </p:txBody>
@@ -4085,7 +4081,7 @@
     <p:bg>
       <p:bgPr>
         <a:solidFill>
-          <a:srgbClr val="F6F1E7"/>
+          <a:srgbClr val="0E1411"/>
         </a:solidFill>
         <a:effectLst/>
       </p:bgPr>
@@ -4097,44 +4093,9 @@
         <p:nvPr/>
       </p:nvGrpSpPr>
       <p:grpSpPr/>
-      <p:sp>
-        <p:nvSpPr>
-          <p:cNvPr id="2" name="TextBox 1"/>
-          <p:cNvSpPr txBox="1"/>
-          <p:nvPr/>
-        </p:nvSpPr>
-        <p:spPr>
-          <a:xfrm>
-            <a:off x="1200000" y="2200000"/>
-            <a:ext cx="9700000" cy="1500000"/>
-          </a:xfrm>
-          <a:prstGeom prst="rect">
-            <a:avLst/>
-          </a:prstGeom>
-          <a:noFill/>
-        </p:spPr>
-        <p:txBody>
-          <a:bodyPr wrap="square">
-            <a:spAutoFit/>
-          </a:bodyPr>
-          <a:lstStyle/>
-          <a:p>
-            <a:pPr algn="ctr"/>
-            <a:r>
-              <a:rPr sz="4400" b="1">
-                <a:solidFill>
-                  <a:srgbClr val="0E1411"/>
-                </a:solidFill>
-                <a:latin typeface="Playfair Display"/>
-              </a:rPr>
-              <a:t>When the Wi-Fi drops, the work doesn't.</a:t>
-            </a:r>
-          </a:p>
-        </p:txBody>
-      </p:sp>
       <p:pic>
         <p:nvPicPr>
-          <p:cNvPr id="3" name="Picture 2" descr="gold-deco-hairline.png"/>
+          <p:cNvPr id="2" name="Picture 1" descr="kente-texture-overlay.png"/>
           <p:cNvPicPr>
             <a:picLocks noChangeAspect="1"/>
           </p:cNvPicPr>
@@ -4148,8 +4109,8 @@
         </p:blipFill>
         <p:spPr>
           <a:xfrm>
-            <a:off x="5896000" y="3800000"/>
-            <a:ext cx="400000" cy="20000"/>
+            <a:off x="0" y="0"/>
+            <a:ext cx="12192000" cy="6858000"/>
           </a:xfrm>
           <a:prstGeom prst="rect">
             <a:avLst/>
@@ -4158,14 +4119,14 @@
       </p:pic>
       <p:sp>
         <p:nvSpPr>
-          <p:cNvPr id="4" name="TextBox 3"/>
+          <p:cNvPr id="3" name="TextBox 2"/>
           <p:cNvSpPr txBox="1"/>
           <p:nvPr/>
         </p:nvSpPr>
         <p:spPr>
           <a:xfrm>
-            <a:off x="1500000" y="4100000"/>
-            <a:ext cx="9100000" cy="1200000"/>
+            <a:off x="1600000" y="2800000"/>
+            <a:ext cx="8900000" cy="2000000"/>
           </a:xfrm>
           <a:prstGeom prst="rect">
             <a:avLst/>
@@ -4180,48 +4141,13 @@
           <a:p>
             <a:pPr algn="ctr"/>
             <a:r>
-              <a:rPr sz="2200" b="0">
-                <a:solidFill>
-                  <a:srgbClr val="1A1714"/>
-                </a:solidFill>
-                <a:latin typeface="DM Sans"/>
+              <a:rPr sz="4400" b="0">
+                <a:solidFill>
+                  <a:srgbClr val="F6F1E7"/>
+                </a:solidFill>
+                <a:latin typeface="Playfair Display"/>
               </a:rPr>
-              <a:t>Both apps queue mutations locally and replay them on reconnect.</a:t>
-            </a:r>
-          </a:p>
-        </p:txBody>
-      </p:sp>
-      <p:sp>
-        <p:nvSpPr>
-          <p:cNvPr id="5" name="TextBox 4"/>
-          <p:cNvSpPr txBox="1"/>
-          <p:nvPr/>
-        </p:nvSpPr>
-        <p:spPr>
-          <a:xfrm>
-            <a:off x="8000000" y="6500000"/>
-            <a:ext cx="4000000" cy="300000"/>
-          </a:xfrm>
-          <a:prstGeom prst="rect">
-            <a:avLst/>
-          </a:prstGeom>
-          <a:noFill/>
-        </p:spPr>
-        <p:txBody>
-          <a:bodyPr wrap="square">
-            <a:spAutoFit/>
-          </a:bodyPr>
-          <a:lstStyle/>
-          <a:p>
-            <a:pPr algn="r"/>
-            <a:r>
-              <a:rPr sz="1100" b="0">
-                <a:solidFill>
-                  <a:srgbClr val="D8CFBE"/>
-                </a:solidFill>
-                <a:latin typeface="DM Sans"/>
-              </a:rPr>
-              <a:t>01 · The Story So Far · 13/18</a:t>
+              <a:t>SmartGate isn't a product. It's how OHCS shows up for itself.</a:t>
             </a:r>
           </a:p>
         </p:txBody>
@@ -4260,8 +4186,8 @@
         </p:nvSpPr>
         <p:spPr>
           <a:xfrm>
-            <a:off x="1200000" y="2200000"/>
-            <a:ext cx="9700000" cy="1500000"/>
+            <a:off x="1000000" y="800000"/>
+            <a:ext cx="10000000" cy="700000"/>
           </a:xfrm>
           <a:prstGeom prst="rect">
             <a:avLst/>
@@ -4274,7 +4200,7 @@
           </a:bodyPr>
           <a:lstStyle/>
           <a:p>
-            <a:pPr algn="ctr"/>
+            <a:pPr algn="l"/>
             <a:r>
               <a:rPr sz="4400" b="1">
                 <a:solidFill>
@@ -4282,45 +4208,21 @@
                 </a:solidFill>
                 <a:latin typeface="Playfair Display"/>
               </a:rPr>
-              <a:t>Security shipped in writing.</a:t>
-            </a:r>
-          </a:p>
-        </p:txBody>
-      </p:sp>
-      <p:pic>
-        <p:nvPicPr>
-          <p:cNvPr id="3" name="Picture 2" descr="gold-deco-hairline.png"/>
-          <p:cNvPicPr>
-            <a:picLocks noChangeAspect="1"/>
-          </p:cNvPicPr>
-          <p:nvPr/>
-        </p:nvPicPr>
-        <p:blipFill>
-          <a:blip r:embed="rId2"/>
-          <a:stretch>
-            <a:fillRect/>
-          </a:stretch>
-        </p:blipFill>
-        <p:spPr>
-          <a:xfrm>
-            <a:off x="5896000" y="3800000"/>
-            <a:ext cx="400000" cy="20000"/>
-          </a:xfrm>
-          <a:prstGeom prst="rect">
-            <a:avLst/>
-          </a:prstGeom>
-        </p:spPr>
-      </p:pic>
-      <p:sp>
-        <p:nvSpPr>
-          <p:cNvPr id="4" name="TextBox 3"/>
+              <a:t>Appendix</a:t>
+            </a:r>
+          </a:p>
+        </p:txBody>
+      </p:sp>
+      <p:sp>
+        <p:nvSpPr>
+          <p:cNvPr id="3" name="TextBox 2"/>
           <p:cNvSpPr txBox="1"/>
           <p:nvPr/>
         </p:nvSpPr>
         <p:spPr>
           <a:xfrm>
-            <a:off x="1500000" y="4100000"/>
-            <a:ext cx="9100000" cy="1200000"/>
+            <a:off x="1000000" y="2000000"/>
+            <a:ext cx="5000000" cy="400000"/>
           </a:xfrm>
           <a:prstGeom prst="rect">
             <a:avLst/>
@@ -4333,29 +4235,29 @@
           </a:bodyPr>
           <a:lstStyle/>
           <a:p>
-            <a:pPr algn="ctr"/>
-            <a:r>
-              <a:rPr sz="2200" b="0">
-                <a:solidFill>
-                  <a:srgbClr val="1A1714"/>
+            <a:pPr algn="l"/>
+            <a:r>
+              <a:rPr sz="1800" b="1">
+                <a:solidFill>
+                  <a:srgbClr val="8B6B22"/>
                 </a:solidFill>
                 <a:latin typeface="DM Sans"/>
               </a:rPr>
-              <a:t>Twelve fixes. Constant-time PIN. Self-hosted Web Push. RBAC. Audited migrations.</a:t>
-            </a:r>
-          </a:p>
-        </p:txBody>
-      </p:sp>
-      <p:sp>
-        <p:nvSpPr>
-          <p:cNvPr id="5" name="TextBox 4"/>
+              <a:t>Live URLs</a:t>
+            </a:r>
+          </a:p>
+        </p:txBody>
+      </p:sp>
+      <p:sp>
+        <p:nvSpPr>
+          <p:cNvPr id="4" name="TextBox 3"/>
           <p:cNvSpPr txBox="1"/>
           <p:nvPr/>
         </p:nvSpPr>
         <p:spPr>
           <a:xfrm>
-            <a:off x="8000000" y="6500000"/>
-            <a:ext cx="4000000" cy="300000"/>
+            <a:off x="1000000" y="2500000"/>
+            <a:ext cx="5000000" cy="400000"/>
           </a:xfrm>
           <a:prstGeom prst="rect">
             <a:avLst/>
@@ -4368,55 +4270,29 @@
           </a:bodyPr>
           <a:lstStyle/>
           <a:p>
-            <a:pPr algn="r"/>
-            <a:r>
-              <a:rPr sz="1100" b="0">
-                <a:solidFill>
-                  <a:srgbClr val="D8CFBE"/>
+            <a:pPr algn="l"/>
+            <a:r>
+              <a:rPr sz="1400" b="0">
+                <a:solidFill>
+                  <a:srgbClr val="1A1714"/>
                 </a:solidFill>
                 <a:latin typeface="DM Sans"/>
               </a:rPr>
-              <a:t>01 · The Story So Far · 14/18</a:t>
-            </a:r>
-          </a:p>
-        </p:txBody>
-      </p:sp>
-    </p:spTree>
-  </p:cSld>
-  <p:clrMapOvr>
-    <a:masterClrMapping/>
-  </p:clrMapOvr>
-</p:sld>
-</file>
-
-<file path=ppt/slides/slide15.xml><?xml version="1.0" encoding="utf-8"?>
-<p:sld xmlns:a="http://schemas.openxmlformats.org/drawingml/2006/main" xmlns:p="http://schemas.openxmlformats.org/presentationml/2006/main" xmlns:r="http://schemas.openxmlformats.org/officeDocument/2006/relationships">
-  <p:cSld>
-    <p:bg>
-      <p:bgPr>
-        <a:solidFill>
-          <a:srgbClr val="F6F1E7"/>
-        </a:solidFill>
-        <a:effectLst/>
-      </p:bgPr>
-    </p:bg>
-    <p:spTree>
-      <p:nvGrpSpPr>
-        <p:cNvPr id="1" name=""/>
-        <p:cNvGrpSpPr/>
-        <p:nvPr/>
-      </p:nvGrpSpPr>
-      <p:grpSpPr/>
-      <p:sp>
-        <p:nvSpPr>
-          <p:cNvPr id="2" name="TextBox 1"/>
+              <a:t>staff-attendance.pages.dev</a:t>
+            </a:r>
+          </a:p>
+        </p:txBody>
+      </p:sp>
+      <p:sp>
+        <p:nvSpPr>
+          <p:cNvPr id="5" name="TextBox 4"/>
           <p:cNvSpPr txBox="1"/>
           <p:nvPr/>
         </p:nvSpPr>
         <p:spPr>
           <a:xfrm>
-            <a:off x="1200000" y="2200000"/>
-            <a:ext cx="9700000" cy="1500000"/>
+            <a:off x="1000000" y="2900000"/>
+            <a:ext cx="5000000" cy="400000"/>
           </a:xfrm>
           <a:prstGeom prst="rect">
             <a:avLst/>
@@ -4429,53 +4305,29 @@
           </a:bodyPr>
           <a:lstStyle/>
           <a:p>
-            <a:pPr algn="ctr"/>
-            <a:r>
-              <a:rPr sz="4400" b="1">
-                <a:solidFill>
-                  <a:srgbClr val="0E1411"/>
-                </a:solidFill>
-                <a:latin typeface="Playfair Display"/>
+            <a:pPr algn="l"/>
+            <a:r>
+              <a:rPr sz="1400" b="0">
+                <a:solidFill>
+                  <a:srgbClr val="1A1714"/>
+                </a:solidFill>
+                <a:latin typeface="DM Sans"/>
               </a:rPr>
-              <a:t>Designed in a civic register.</a:t>
-            </a:r>
-          </a:p>
-        </p:txBody>
-      </p:sp>
-      <p:pic>
-        <p:nvPicPr>
-          <p:cNvPr id="3" name="Picture 2" descr="gold-deco-hairline.png"/>
-          <p:cNvPicPr>
-            <a:picLocks noChangeAspect="1"/>
-          </p:cNvPicPr>
-          <p:nvPr/>
-        </p:nvPicPr>
-        <p:blipFill>
-          <a:blip r:embed="rId2"/>
-          <a:stretch>
-            <a:fillRect/>
-          </a:stretch>
-        </p:blipFill>
-        <p:spPr>
-          <a:xfrm>
-            <a:off x="5896000" y="3800000"/>
-            <a:ext cx="400000" cy="20000"/>
-          </a:xfrm>
-          <a:prstGeom prst="rect">
-            <a:avLst/>
-          </a:prstGeom>
-        </p:spPr>
-      </p:pic>
-      <p:sp>
-        <p:nvSpPr>
-          <p:cNvPr id="4" name="TextBox 3"/>
+              <a:t>ohcs-smartgate.pages.dev</a:t>
+            </a:r>
+          </a:p>
+        </p:txBody>
+      </p:sp>
+      <p:sp>
+        <p:nvSpPr>
+          <p:cNvPr id="6" name="TextBox 5"/>
           <p:cNvSpPr txBox="1"/>
           <p:nvPr/>
         </p:nvSpPr>
         <p:spPr>
           <a:xfrm>
-            <a:off x="1500000" y="4100000"/>
-            <a:ext cx="9100000" cy="1200000"/>
+            <a:off x="1000000" y="3300000"/>
+            <a:ext cx="5000000" cy="400000"/>
           </a:xfrm>
           <a:prstGeom prst="rect">
             <a:avLst/>
@@ -4488,29 +4340,29 @@
           </a:bodyPr>
           <a:lstStyle/>
           <a:p>
-            <a:pPr algn="ctr"/>
-            <a:r>
-              <a:rPr sz="2200" b="0">
+            <a:pPr algn="l"/>
+            <a:r>
+              <a:rPr sz="1400" b="0">
                 <a:solidFill>
                   <a:srgbClr val="1A1714"/>
                 </a:solidFill>
                 <a:latin typeface="DM Sans"/>
               </a:rPr>
-              <a:t>Kente Executive — Playfair Display, gold deco, Ghanaian Kente texture. Cultural, not decorative.</a:t>
-            </a:r>
-          </a:p>
-        </p:txBody>
-      </p:sp>
-      <p:sp>
-        <p:nvSpPr>
-          <p:cNvPr id="5" name="TextBox 4"/>
+              <a:t>ohcs-smartgate-api.ghwmelite.workers.dev</a:t>
+            </a:r>
+          </a:p>
+        </p:txBody>
+      </p:sp>
+      <p:sp>
+        <p:nvSpPr>
+          <p:cNvPr id="7" name="TextBox 6"/>
           <p:cNvSpPr txBox="1"/>
           <p:nvPr/>
         </p:nvSpPr>
         <p:spPr>
           <a:xfrm>
-            <a:off x="8000000" y="6500000"/>
-            <a:ext cx="4000000" cy="300000"/>
+            <a:off x="7000000" y="2000000"/>
+            <a:ext cx="5000000" cy="400000"/>
           </a:xfrm>
           <a:prstGeom prst="rect">
             <a:avLst/>
@@ -4523,55 +4375,29 @@
           </a:bodyPr>
           <a:lstStyle/>
           <a:p>
-            <a:pPr algn="r"/>
-            <a:r>
-              <a:rPr sz="1100" b="0">
-                <a:solidFill>
-                  <a:srgbClr val="D8CFBE"/>
+            <a:pPr algn="l"/>
+            <a:r>
+              <a:rPr sz="1800" b="1">
+                <a:solidFill>
+                  <a:srgbClr val="8B6B22"/>
                 </a:solidFill>
                 <a:latin typeface="DM Sans"/>
               </a:rPr>
-              <a:t>01 · The Story So Far · 15/18</a:t>
-            </a:r>
-          </a:p>
-        </p:txBody>
-      </p:sp>
-    </p:spTree>
-  </p:cSld>
-  <p:clrMapOvr>
-    <a:masterClrMapping/>
-  </p:clrMapOvr>
-</p:sld>
-</file>
-
-<file path=ppt/slides/slide16.xml><?xml version="1.0" encoding="utf-8"?>
-<p:sld xmlns:a="http://schemas.openxmlformats.org/drawingml/2006/main" xmlns:p="http://schemas.openxmlformats.org/presentationml/2006/main" xmlns:r="http://schemas.openxmlformats.org/officeDocument/2006/relationships">
-  <p:cSld>
-    <p:bg>
-      <p:bgPr>
-        <a:solidFill>
-          <a:srgbClr val="F6F1E7"/>
-        </a:solidFill>
-        <a:effectLst/>
-      </p:bgPr>
-    </p:bg>
-    <p:spTree>
-      <p:nvGrpSpPr>
-        <p:cNvPr id="1" name=""/>
-        <p:cNvGrpSpPr/>
-        <p:nvPr/>
-      </p:nvGrpSpPr>
-      <p:grpSpPr/>
-      <p:sp>
-        <p:nvSpPr>
-          <p:cNvPr id="2" name="TextBox 1"/>
+              <a:t>Related decks</a:t>
+            </a:r>
+          </a:p>
+        </p:txBody>
+      </p:sp>
+      <p:sp>
+        <p:nvSpPr>
+          <p:cNvPr id="8" name="TextBox 7"/>
           <p:cNvSpPr txBox="1"/>
           <p:nvPr/>
         </p:nvSpPr>
         <p:spPr>
           <a:xfrm>
-            <a:off x="1200000" y="2200000"/>
-            <a:ext cx="9700000" cy="1500000"/>
+            <a:off x="7000000" y="2500000"/>
+            <a:ext cx="5000000" cy="400000"/>
           </a:xfrm>
           <a:prstGeom prst="rect">
             <a:avLst/>
@@ -4584,53 +4410,29 @@
           </a:bodyPr>
           <a:lstStyle/>
           <a:p>
-            <a:pPr algn="ctr"/>
-            <a:r>
-              <a:rPr sz="4400" b="1">
-                <a:solidFill>
-                  <a:srgbClr val="0E1411"/>
-                </a:solidFill>
-                <a:latin typeface="Playfair Display"/>
+            <a:pPr algn="l"/>
+            <a:r>
+              <a:rPr sz="1400" b="0">
+                <a:solidFill>
+                  <a:srgbClr val="1A1714"/>
+                </a:solidFill>
+                <a:latin typeface="DM Sans"/>
               </a:rPr>
-              <a:t>Care continues.</a:t>
-            </a:r>
-          </a:p>
-        </p:txBody>
-      </p:sp>
-      <p:pic>
-        <p:nvPicPr>
-          <p:cNvPr id="3" name="Picture 2" descr="gold-deco-hairline.png"/>
-          <p:cNvPicPr>
-            <a:picLocks noChangeAspect="1"/>
-          </p:cNvPicPr>
-          <p:nvPr/>
-        </p:nvPicPr>
-        <p:blipFill>
-          <a:blip r:embed="rId2"/>
-          <a:stretch>
-            <a:fillRect/>
-          </a:stretch>
-        </p:blipFill>
-        <p:spPr>
-          <a:xfrm>
-            <a:off x="5896000" y="3800000"/>
-            <a:ext cx="400000" cy="20000"/>
-          </a:xfrm>
-          <a:prstGeom prst="rect">
-            <a:avLst/>
-          </a:prstGeom>
-        </p:spPr>
-      </p:pic>
-      <p:sp>
-        <p:nvSpPr>
-          <p:cNvPr id="4" name="TextBox 3"/>
+              <a:t>Deck 02 · SmartGate Spotlight</a:t>
+            </a:r>
+          </a:p>
+        </p:txBody>
+      </p:sp>
+      <p:sp>
+        <p:nvSpPr>
+          <p:cNvPr id="9" name="TextBox 8"/>
           <p:cNvSpPr txBox="1"/>
           <p:nvPr/>
         </p:nvSpPr>
         <p:spPr>
           <a:xfrm>
-            <a:off x="1500000" y="4100000"/>
-            <a:ext cx="9100000" cy="1200000"/>
+            <a:off x="7000000" y="2900000"/>
+            <a:ext cx="5000000" cy="400000"/>
           </a:xfrm>
           <a:prstGeom prst="rect">
             <a:avLst/>
@@ -4643,29 +4445,29 @@
           </a:bodyPr>
           <a:lstStyle/>
           <a:p>
-            <a:pPr algn="ctr"/>
-            <a:r>
-              <a:rPr sz="2200" b="0">
+            <a:pPr algn="l"/>
+            <a:r>
+              <a:rPr sz="1400" b="0">
                 <a:solidFill>
                   <a:srgbClr val="1A1714"/>
                 </a:solidFill>
                 <a:latin typeface="DM Sans"/>
               </a:rPr>
-              <a:t>Automated tests, bundle optimisation, manifest shortcuts, iOS startup images — stewardship, not unfinished work.</a:t>
-            </a:r>
-          </a:p>
-        </p:txBody>
-      </p:sp>
-      <p:sp>
-        <p:nvSpPr>
-          <p:cNvPr id="5" name="TextBox 4"/>
+              <a:t>Deck 03 · Staff Attendance Spotlight</a:t>
+            </a:r>
+          </a:p>
+        </p:txBody>
+      </p:sp>
+      <p:sp>
+        <p:nvSpPr>
+          <p:cNvPr id="10" name="TextBox 9"/>
           <p:cNvSpPr txBox="1"/>
           <p:nvPr/>
         </p:nvSpPr>
         <p:spPr>
           <a:xfrm>
-            <a:off x="8000000" y="6500000"/>
-            <a:ext cx="4000000" cy="300000"/>
+            <a:off x="7000000" y="3300000"/>
+            <a:ext cx="5000000" cy="400000"/>
           </a:xfrm>
           <a:prstGeom prst="rect">
             <a:avLst/>
@@ -4678,79 +4480,29 @@
           </a:bodyPr>
           <a:lstStyle/>
           <a:p>
-            <a:pPr algn="r"/>
-            <a:r>
-              <a:rPr sz="1100" b="0">
-                <a:solidFill>
-                  <a:srgbClr val="D8CFBE"/>
+            <a:pPr algn="l"/>
+            <a:r>
+              <a:rPr sz="1400" b="0">
+                <a:solidFill>
+                  <a:srgbClr val="1A1714"/>
                 </a:solidFill>
                 <a:latin typeface="DM Sans"/>
               </a:rPr>
-              <a:t>01 · The Story So Far · 16/18</a:t>
-            </a:r>
-          </a:p>
-        </p:txBody>
-      </p:sp>
-    </p:spTree>
-  </p:cSld>
-  <p:clrMapOvr>
-    <a:masterClrMapping/>
-  </p:clrMapOvr>
-</p:sld>
-</file>
-
-<file path=ppt/slides/slide17.xml><?xml version="1.0" encoding="utf-8"?>
-<p:sld xmlns:a="http://schemas.openxmlformats.org/drawingml/2006/main" xmlns:p="http://schemas.openxmlformats.org/presentationml/2006/main" xmlns:r="http://schemas.openxmlformats.org/officeDocument/2006/relationships">
-  <p:cSld>
-    <p:bg>
-      <p:bgPr>
-        <a:solidFill>
-          <a:srgbClr val="0E1411"/>
-        </a:solidFill>
-        <a:effectLst/>
-      </p:bgPr>
-    </p:bg>
-    <p:spTree>
-      <p:nvGrpSpPr>
-        <p:cNvPr id="1" name=""/>
-        <p:cNvGrpSpPr/>
-        <p:nvPr/>
-      </p:nvGrpSpPr>
-      <p:grpSpPr/>
-      <p:pic>
-        <p:nvPicPr>
-          <p:cNvPr id="2" name="Picture 1" descr="kente-texture-overlay.png"/>
-          <p:cNvPicPr>
-            <a:picLocks noChangeAspect="1"/>
-          </p:cNvPicPr>
-          <p:nvPr/>
-        </p:nvPicPr>
-        <p:blipFill>
-          <a:blip r:embed="rId2"/>
-          <a:stretch>
-            <a:fillRect/>
-          </a:stretch>
-        </p:blipFill>
-        <p:spPr>
-          <a:xfrm>
-            <a:off x="0" y="0"/>
-            <a:ext cx="12192000" cy="6858000"/>
-          </a:xfrm>
-          <a:prstGeom prst="rect">
-            <a:avLst/>
-          </a:prstGeom>
-        </p:spPr>
-      </p:pic>
-      <p:sp>
-        <p:nvSpPr>
-          <p:cNvPr id="3" name="TextBox 2"/>
+              <a:t>Deck 13 · Roadmap</a:t>
+            </a:r>
+          </a:p>
+        </p:txBody>
+      </p:sp>
+      <p:sp>
+        <p:nvSpPr>
+          <p:cNvPr id="11" name="TextBox 10"/>
           <p:cNvSpPr txBox="1"/>
           <p:nvPr/>
         </p:nvSpPr>
         <p:spPr>
           <a:xfrm>
-            <a:off x="1600000" y="2800000"/>
-            <a:ext cx="8900000" cy="2000000"/>
+            <a:off x="1000000" y="6300000"/>
+            <a:ext cx="10000000" cy="400000"/>
           </a:xfrm>
           <a:prstGeom prst="rect">
             <a:avLst/>
@@ -4765,53 +4517,27 @@
           <a:p>
             <a:pPr algn="ctr"/>
             <a:r>
-              <a:rPr sz="4400" b="0">
-                <a:solidFill>
-                  <a:srgbClr val="F6F1E7"/>
-                </a:solidFill>
-                <a:latin typeface="Playfair Display"/>
+              <a:rPr sz="1100" b="0">
+                <a:solidFill>
+                  <a:srgbClr val="8B6B22"/>
+                </a:solidFill>
+                <a:latin typeface="DM Sans"/>
               </a:rPr>
-              <a:t>SmartGate isn't a product. It's how OHCS shows up for itself.</a:t>
-            </a:r>
-          </a:p>
-        </p:txBody>
-      </p:sp>
-    </p:spTree>
-  </p:cSld>
-  <p:clrMapOvr>
-    <a:masterClrMapping/>
-  </p:clrMapOvr>
-</p:sld>
-</file>
-
-<file path=ppt/slides/slide18.xml><?xml version="1.0" encoding="utf-8"?>
-<p:sld xmlns:a="http://schemas.openxmlformats.org/drawingml/2006/main" xmlns:p="http://schemas.openxmlformats.org/presentationml/2006/main" xmlns:r="http://schemas.openxmlformats.org/officeDocument/2006/relationships">
-  <p:cSld>
-    <p:bg>
-      <p:bgPr>
-        <a:solidFill>
-          <a:srgbClr val="F6F1E7"/>
-        </a:solidFill>
-        <a:effectLst/>
-      </p:bgPr>
-    </p:bg>
-    <p:spTree>
-      <p:nvGrpSpPr>
-        <p:cNvPr id="1" name=""/>
-        <p:cNvGrpSpPr/>
-        <p:nvPr/>
-      </p:nvGrpSpPr>
-      <p:grpSpPr/>
-      <p:sp>
-        <p:nvSpPr>
-          <p:cNvPr id="2" name="TextBox 1"/>
+              <a:t>Built on Cloudflare's edge · Designed in the Kente Executive language</a:t>
+            </a:r>
+          </a:p>
+        </p:txBody>
+      </p:sp>
+      <p:sp>
+        <p:nvSpPr>
+          <p:cNvPr id="12" name="TextBox 11"/>
           <p:cNvSpPr txBox="1"/>
           <p:nvPr/>
         </p:nvSpPr>
         <p:spPr>
           <a:xfrm>
-            <a:off x="1000000" y="800000"/>
-            <a:ext cx="10000000" cy="700000"/>
+            <a:off x="8000000" y="6500000"/>
+            <a:ext cx="4000000" cy="300000"/>
           </a:xfrm>
           <a:prstGeom prst="rect">
             <a:avLst/>
@@ -4824,365 +4550,15 @@
           </a:bodyPr>
           <a:lstStyle/>
           <a:p>
-            <a:pPr algn="l"/>
-            <a:r>
-              <a:rPr sz="4400" b="1">
-                <a:solidFill>
-                  <a:srgbClr val="0E1411"/>
-                </a:solidFill>
-                <a:latin typeface="Playfair Display"/>
-              </a:rPr>
-              <a:t>Appendix</a:t>
-            </a:r>
-          </a:p>
-        </p:txBody>
-      </p:sp>
-      <p:sp>
-        <p:nvSpPr>
-          <p:cNvPr id="3" name="TextBox 2"/>
-          <p:cNvSpPr txBox="1"/>
-          <p:nvPr/>
-        </p:nvSpPr>
-        <p:spPr>
-          <a:xfrm>
-            <a:off x="1000000" y="2000000"/>
-            <a:ext cx="5000000" cy="400000"/>
-          </a:xfrm>
-          <a:prstGeom prst="rect">
-            <a:avLst/>
-          </a:prstGeom>
-          <a:noFill/>
-        </p:spPr>
-        <p:txBody>
-          <a:bodyPr wrap="square">
-            <a:spAutoFit/>
-          </a:bodyPr>
-          <a:lstStyle/>
-          <a:p>
-            <a:pPr algn="l"/>
-            <a:r>
-              <a:rPr sz="1800" b="1">
-                <a:solidFill>
-                  <a:srgbClr val="8B6B22"/>
+            <a:pPr algn="r"/>
+            <a:r>
+              <a:rPr sz="1100" b="0">
+                <a:solidFill>
+                  <a:srgbClr val="D8CFBE"/>
                 </a:solidFill>
                 <a:latin typeface="DM Sans"/>
               </a:rPr>
-              <a:t>Live URLs</a:t>
-            </a:r>
-          </a:p>
-        </p:txBody>
-      </p:sp>
-      <p:sp>
-        <p:nvSpPr>
-          <p:cNvPr id="4" name="TextBox 3"/>
-          <p:cNvSpPr txBox="1"/>
-          <p:nvPr/>
-        </p:nvSpPr>
-        <p:spPr>
-          <a:xfrm>
-            <a:off x="1000000" y="2500000"/>
-            <a:ext cx="5000000" cy="400000"/>
-          </a:xfrm>
-          <a:prstGeom prst="rect">
-            <a:avLst/>
-          </a:prstGeom>
-          <a:noFill/>
-        </p:spPr>
-        <p:txBody>
-          <a:bodyPr wrap="square">
-            <a:spAutoFit/>
-          </a:bodyPr>
-          <a:lstStyle/>
-          <a:p>
-            <a:pPr algn="l"/>
-            <a:r>
-              <a:rPr sz="1400" b="0">
-                <a:solidFill>
-                  <a:srgbClr val="1A1714"/>
-                </a:solidFill>
-                <a:latin typeface="DM Sans"/>
-              </a:rPr>
-              <a:t>staff-attendance.pages.dev</a:t>
-            </a:r>
-          </a:p>
-        </p:txBody>
-      </p:sp>
-      <p:sp>
-        <p:nvSpPr>
-          <p:cNvPr id="5" name="TextBox 4"/>
-          <p:cNvSpPr txBox="1"/>
-          <p:nvPr/>
-        </p:nvSpPr>
-        <p:spPr>
-          <a:xfrm>
-            <a:off x="1000000" y="2900000"/>
-            <a:ext cx="5000000" cy="400000"/>
-          </a:xfrm>
-          <a:prstGeom prst="rect">
-            <a:avLst/>
-          </a:prstGeom>
-          <a:noFill/>
-        </p:spPr>
-        <p:txBody>
-          <a:bodyPr wrap="square">
-            <a:spAutoFit/>
-          </a:bodyPr>
-          <a:lstStyle/>
-          <a:p>
-            <a:pPr algn="l"/>
-            <a:r>
-              <a:rPr sz="1400" b="0">
-                <a:solidFill>
-                  <a:srgbClr val="1A1714"/>
-                </a:solidFill>
-                <a:latin typeface="DM Sans"/>
-              </a:rPr>
-              <a:t>ohcs-smartgate.pages.dev</a:t>
-            </a:r>
-          </a:p>
-        </p:txBody>
-      </p:sp>
-      <p:sp>
-        <p:nvSpPr>
-          <p:cNvPr id="6" name="TextBox 5"/>
-          <p:cNvSpPr txBox="1"/>
-          <p:nvPr/>
-        </p:nvSpPr>
-        <p:spPr>
-          <a:xfrm>
-            <a:off x="1000000" y="3300000"/>
-            <a:ext cx="5000000" cy="400000"/>
-          </a:xfrm>
-          <a:prstGeom prst="rect">
-            <a:avLst/>
-          </a:prstGeom>
-          <a:noFill/>
-        </p:spPr>
-        <p:txBody>
-          <a:bodyPr wrap="square">
-            <a:spAutoFit/>
-          </a:bodyPr>
-          <a:lstStyle/>
-          <a:p>
-            <a:pPr algn="l"/>
-            <a:r>
-              <a:rPr sz="1400" b="0">
-                <a:solidFill>
-                  <a:srgbClr val="1A1714"/>
-                </a:solidFill>
-                <a:latin typeface="DM Sans"/>
-              </a:rPr>
-              <a:t>ohcs-smartgate-api.ghwmelite.workers.dev</a:t>
-            </a:r>
-          </a:p>
-        </p:txBody>
-      </p:sp>
-      <p:sp>
-        <p:nvSpPr>
-          <p:cNvPr id="7" name="TextBox 6"/>
-          <p:cNvSpPr txBox="1"/>
-          <p:nvPr/>
-        </p:nvSpPr>
-        <p:spPr>
-          <a:xfrm>
-            <a:off x="7000000" y="2000000"/>
-            <a:ext cx="5000000" cy="400000"/>
-          </a:xfrm>
-          <a:prstGeom prst="rect">
-            <a:avLst/>
-          </a:prstGeom>
-          <a:noFill/>
-        </p:spPr>
-        <p:txBody>
-          <a:bodyPr wrap="square">
-            <a:spAutoFit/>
-          </a:bodyPr>
-          <a:lstStyle/>
-          <a:p>
-            <a:pPr algn="l"/>
-            <a:r>
-              <a:rPr sz="1800" b="1">
-                <a:solidFill>
-                  <a:srgbClr val="8B6B22"/>
-                </a:solidFill>
-                <a:latin typeface="DM Sans"/>
-              </a:rPr>
-              <a:t>Related decks</a:t>
-            </a:r>
-          </a:p>
-        </p:txBody>
-      </p:sp>
-      <p:sp>
-        <p:nvSpPr>
-          <p:cNvPr id="8" name="TextBox 7"/>
-          <p:cNvSpPr txBox="1"/>
-          <p:nvPr/>
-        </p:nvSpPr>
-        <p:spPr>
-          <a:xfrm>
-            <a:off x="7000000" y="2500000"/>
-            <a:ext cx="5000000" cy="400000"/>
-          </a:xfrm>
-          <a:prstGeom prst="rect">
-            <a:avLst/>
-          </a:prstGeom>
-          <a:noFill/>
-        </p:spPr>
-        <p:txBody>
-          <a:bodyPr wrap="square">
-            <a:spAutoFit/>
-          </a:bodyPr>
-          <a:lstStyle/>
-          <a:p>
-            <a:pPr algn="l"/>
-            <a:r>
-              <a:rPr sz="1400" b="0">
-                <a:solidFill>
-                  <a:srgbClr val="1A1714"/>
-                </a:solidFill>
-                <a:latin typeface="DM Sans"/>
-              </a:rPr>
-              <a:t>Deck 02 · SmartGate Spotlight</a:t>
-            </a:r>
-          </a:p>
-        </p:txBody>
-      </p:sp>
-      <p:sp>
-        <p:nvSpPr>
-          <p:cNvPr id="9" name="TextBox 8"/>
-          <p:cNvSpPr txBox="1"/>
-          <p:nvPr/>
-        </p:nvSpPr>
-        <p:spPr>
-          <a:xfrm>
-            <a:off x="7000000" y="2900000"/>
-            <a:ext cx="5000000" cy="400000"/>
-          </a:xfrm>
-          <a:prstGeom prst="rect">
-            <a:avLst/>
-          </a:prstGeom>
-          <a:noFill/>
-        </p:spPr>
-        <p:txBody>
-          <a:bodyPr wrap="square">
-            <a:spAutoFit/>
-          </a:bodyPr>
-          <a:lstStyle/>
-          <a:p>
-            <a:pPr algn="l"/>
-            <a:r>
-              <a:rPr sz="1400" b="0">
-                <a:solidFill>
-                  <a:srgbClr val="1A1714"/>
-                </a:solidFill>
-                <a:latin typeface="DM Sans"/>
-              </a:rPr>
-              <a:t>Deck 03 · Staff Attendance Spotlight</a:t>
-            </a:r>
-          </a:p>
-        </p:txBody>
-      </p:sp>
-      <p:sp>
-        <p:nvSpPr>
-          <p:cNvPr id="10" name="TextBox 9"/>
-          <p:cNvSpPr txBox="1"/>
-          <p:nvPr/>
-        </p:nvSpPr>
-        <p:spPr>
-          <a:xfrm>
-            <a:off x="7000000" y="3300000"/>
-            <a:ext cx="5000000" cy="400000"/>
-          </a:xfrm>
-          <a:prstGeom prst="rect">
-            <a:avLst/>
-          </a:prstGeom>
-          <a:noFill/>
-        </p:spPr>
-        <p:txBody>
-          <a:bodyPr wrap="square">
-            <a:spAutoFit/>
-          </a:bodyPr>
-          <a:lstStyle/>
-          <a:p>
-            <a:pPr algn="l"/>
-            <a:r>
-              <a:rPr sz="1400" b="0">
-                <a:solidFill>
-                  <a:srgbClr val="1A1714"/>
-                </a:solidFill>
-                <a:latin typeface="DM Sans"/>
-              </a:rPr>
-              <a:t>Deck 13 · Roadmap</a:t>
-            </a:r>
-          </a:p>
-        </p:txBody>
-      </p:sp>
-      <p:sp>
-        <p:nvSpPr>
-          <p:cNvPr id="11" name="TextBox 10"/>
-          <p:cNvSpPr txBox="1"/>
-          <p:nvPr/>
-        </p:nvSpPr>
-        <p:spPr>
-          <a:xfrm>
-            <a:off x="1000000" y="6300000"/>
-            <a:ext cx="10000000" cy="400000"/>
-          </a:xfrm>
-          <a:prstGeom prst="rect">
-            <a:avLst/>
-          </a:prstGeom>
-          <a:noFill/>
-        </p:spPr>
-        <p:txBody>
-          <a:bodyPr wrap="square">
-            <a:spAutoFit/>
-          </a:bodyPr>
-          <a:lstStyle/>
-          <a:p>
-            <a:pPr algn="ctr"/>
-            <a:r>
-              <a:rPr sz="1100" b="0">
-                <a:solidFill>
-                  <a:srgbClr val="8B6B22"/>
-                </a:solidFill>
-                <a:latin typeface="DM Sans"/>
-              </a:rPr>
-              <a:t>Built on Cloudflare's edge · Designed in the Kente Executive language</a:t>
-            </a:r>
-          </a:p>
-        </p:txBody>
-      </p:sp>
-      <p:sp>
-        <p:nvSpPr>
-          <p:cNvPr id="12" name="TextBox 11"/>
-          <p:cNvSpPr txBox="1"/>
-          <p:nvPr/>
-        </p:nvSpPr>
-        <p:spPr>
-          <a:xfrm>
-            <a:off x="8000000" y="6500000"/>
-            <a:ext cx="4000000" cy="300000"/>
-          </a:xfrm>
-          <a:prstGeom prst="rect">
-            <a:avLst/>
-          </a:prstGeom>
-          <a:noFill/>
-        </p:spPr>
-        <p:txBody>
-          <a:bodyPr wrap="square">
-            <a:spAutoFit/>
-          </a:bodyPr>
-          <a:lstStyle/>
-          <a:p>
-            <a:pPr algn="r"/>
-            <a:r>
-              <a:rPr sz="1100" b="0">
-                <a:solidFill>
-                  <a:srgbClr val="D8CFBE"/>
-                </a:solidFill>
-                <a:latin typeface="DM Sans"/>
-              </a:rPr>
-              <a:t>01 · The Story So Far · 18/18</a:t>
+              <a:t>01 · The Story So Far · 14/14</a:t>
             </a:r>
           </a:p>
         </p:txBody>
@@ -5363,7 +4739,7 @@
                 </a:solidFill>
                 <a:latin typeface="DM Sans"/>
               </a:rPr>
-              <a:t>01 · The Story So Far · 03/18</a:t>
+              <a:t>01 · The Story So Far · 03/14</a:t>
             </a:r>
           </a:p>
         </p:txBody>
@@ -5518,7 +4894,7 @@
                 </a:solidFill>
                 <a:latin typeface="DM Sans"/>
               </a:rPr>
-              <a:t>01 · The Story So Far · 04/18</a:t>
+              <a:t>01 · The Story So Far · 04/14</a:t>
             </a:r>
           </a:p>
         </p:txBody>
@@ -5808,7 +5184,7 @@
                 </a:solidFill>
                 <a:latin typeface="DM Sans"/>
               </a:rPr>
-              <a:t>01 · The Story So Far · 05/18</a:t>
+              <a:t>01 · The Story So Far · 05/14</a:t>
             </a:r>
           </a:p>
         </p:txBody>
@@ -5963,7 +5339,7 @@
                 </a:solidFill>
                 <a:latin typeface="DM Sans"/>
               </a:rPr>
-              <a:t>01 · The Story So Far · 06/18</a:t>
+              <a:t>01 · The Story So Far · 06/14</a:t>
             </a:r>
           </a:p>
         </p:txBody>
@@ -6253,7 +5629,7 @@
                 </a:solidFill>
                 <a:latin typeface="DM Sans"/>
               </a:rPr>
-              <a:t>01 · The Story So Far · 07/18</a:t>
+              <a:t>01 · The Story So Far · 07/14</a:t>
             </a:r>
           </a:p>
         </p:txBody>
@@ -6408,7 +5784,7 @@
                 </a:solidFill>
                 <a:latin typeface="DM Sans"/>
               </a:rPr>
-              <a:t>01 · The Story So Far · 08/18</a:t>
+              <a:t>01 · The Story So Far · 08/14</a:t>
             </a:r>
           </a:p>
         </p:txBody>
@@ -6563,7 +5939,7 @@
                 </a:solidFill>
                 <a:latin typeface="DM Sans"/>
               </a:rPr>
-              <a:t>01 · The Story So Far · 09/18</a:t>
+              <a:t>01 · The Story So Far · 09/14</a:t>
             </a:r>
           </a:p>
         </p:txBody>

</xml_diff>